<commit_message>
Add mock call transcript (transparency example) to RAI deck
</commit_message>
<xml_diff>
--- a/usecases/ai_pipeline 2/docs/Responsible_AI_LLMOps.pptx
+++ b/usecases/ai_pipeline 2/docs/Responsible_AI_LLMOps.pptx
@@ -5960,7 +5960,7 @@
                 </a:solidFill>
                 <a:latin typeface="Segoe UI"/>
               </a:rPr>
-              <a:t>WORKED EXAMPLES</a:t>
+              <a:t>WORKED EXAMPLE</a:t>
             </a:r>
           </a:p>
           <a:p>
@@ -5976,7 +5976,7 @@
                 </a:solidFill>
                 <a:latin typeface="Segoe UI"/>
               </a:rPr>
-              <a:t>Fairness and transparency, made concrete</a:t>
+              <a:t>Transparency on a real call — every score has its evidence</a:t>
             </a:r>
           </a:p>
         </p:txBody>
@@ -5989,8 +5989,195 @@
         </p:nvSpPr>
         <p:spPr>
           <a:xfrm>
-            <a:off x="640080" y="1828800"/>
-            <a:ext cx="5486400" cy="3657600"/>
+            <a:off x="640080" y="1737360"/>
+            <a:ext cx="6126480" cy="4069080"/>
+          </a:xfrm>
+          <a:prstGeom prst="roundRect">
+            <a:avLst/>
+          </a:prstGeom>
+          <a:solidFill>
+            <a:srgbClr val="F3F1EA"/>
+          </a:solidFill>
+          <a:ln w="9525">
+            <a:solidFill>
+              <a:srgbClr val="D9DFE5"/>
+            </a:solidFill>
+          </a:ln>
+          <a:effectLst/>
+        </p:spPr>
+        <p:style>
+          <a:lnRef idx="1">
+            <a:schemeClr val="accent1"/>
+          </a:lnRef>
+          <a:fillRef idx="3">
+            <a:schemeClr val="accent1"/>
+          </a:fillRef>
+          <a:effectRef idx="2">
+            <a:schemeClr val="accent1"/>
+          </a:effectRef>
+          <a:fontRef idx="minor">
+            <a:schemeClr val="lt1"/>
+          </a:fontRef>
+        </p:style>
+        <p:txBody>
+          <a:bodyPr rtlCol="0" anchor="ctr" wrap="square" lIns="146304" rIns="128016" tIns="118872" bIns="91440"/>
+          <a:lstStyle/>
+          <a:p>
+            <a:pPr algn="ctr">
+              <a:spcAft>
+                <a:spcPts val="700"/>
+              </a:spcAft>
+            </a:pPr>
+            <a:r>
+              <a:rPr sz="1250" b="1">
+                <a:solidFill>
+                  <a:srgbClr val="0A5B55"/>
+                </a:solidFill>
+                <a:latin typeface="Segoe UI"/>
+              </a:rPr>
+              <a:t>MOCK CALL TRANSCRIPT — APIX example (illustrative)</a:t>
+            </a:r>
+          </a:p>
+          <a:p>
+            <a:pPr>
+              <a:spcAft>
+                <a:spcPts val="300"/>
+              </a:spcAft>
+            </a:pPr>
+            <a:r>
+              <a:rPr sz="1150" b="0">
+                <a:solidFill>
+                  <a:srgbClr val="1A1F27"/>
+                </a:solidFill>
+                <a:latin typeface="Consolas"/>
+              </a:rPr>
+              <a:t>[10] Cust : My phone died right before an</a:t>
+            </a:r>
+          </a:p>
+          <a:p>
+            <a:pPr>
+              <a:spcAft>
+                <a:spcPts val="300"/>
+              </a:spcAft>
+            </a:pPr>
+            <a:r>
+              <a:rPr sz="1150" b="0">
+                <a:solidFill>
+                  <a:srgbClr val="1A1F27"/>
+                </a:solidFill>
+                <a:latin typeface="Consolas"/>
+              </a:rPr>
+              <a:t>            important call. I'm really stressed.</a:t>
+            </a:r>
+          </a:p>
+          <a:p>
+            <a:pPr>
+              <a:spcAft>
+                <a:spcPts val="300"/>
+              </a:spcAft>
+            </a:pPr>
+            <a:r>
+              <a:rPr sz="1150" b="0">
+                <a:solidFill>
+                  <a:srgbClr val="1A1F27"/>
+                </a:solidFill>
+                <a:latin typeface="Consolas"/>
+              </a:rPr>
+              <a:t>[11] Agent: I completely understand how</a:t>
+            </a:r>
+          </a:p>
+          <a:p>
+            <a:pPr>
+              <a:spcAft>
+                <a:spcPts val="300"/>
+              </a:spcAft>
+            </a:pPr>
+            <a:r>
+              <a:rPr sz="1150" b="0">
+                <a:solidFill>
+                  <a:srgbClr val="1A1F27"/>
+                </a:solidFill>
+                <a:latin typeface="Consolas"/>
+              </a:rPr>
+              <a:t>            frustrating that is — let me sort</a:t>
+            </a:r>
+          </a:p>
+          <a:p>
+            <a:pPr>
+              <a:spcAft>
+                <a:spcPts val="300"/>
+              </a:spcAft>
+            </a:pPr>
+            <a:r>
+              <a:rPr sz="1150" b="0">
+                <a:solidFill>
+                  <a:srgbClr val="1A1F27"/>
+                </a:solidFill>
+                <a:latin typeface="Consolas"/>
+              </a:rPr>
+              <a:t>            this out for you right now.</a:t>
+            </a:r>
+          </a:p>
+          <a:p>
+            <a:pPr>
+              <a:spcAft>
+                <a:spcPts val="300"/>
+              </a:spcAft>
+            </a:pPr>
+            <a:r>
+              <a:rPr sz="1150" b="0">
+                <a:solidFill>
+                  <a:srgbClr val="1A1F27"/>
+                </a:solidFill>
+                <a:latin typeface="Consolas"/>
+              </a:rPr>
+              <a:t>[12] Agent: I've fast-tracked a replacement for</a:t>
+            </a:r>
+          </a:p>
+          <a:p>
+            <a:pPr>
+              <a:spcAft>
+                <a:spcPts val="300"/>
+              </a:spcAft>
+            </a:pPr>
+            <a:r>
+              <a:rPr sz="1150" b="0">
+                <a:solidFill>
+                  <a:srgbClr val="1A1F27"/>
+                </a:solidFill>
+                <a:latin typeface="Consolas"/>
+              </a:rPr>
+              <a:t>            tomorrow and added a credit.</a:t>
+            </a:r>
+          </a:p>
+          <a:p>
+            <a:pPr>
+              <a:spcAft>
+                <a:spcPts val="300"/>
+              </a:spcAft>
+            </a:pPr>
+            <a:r>
+              <a:rPr sz="1150" b="0">
+                <a:solidFill>
+                  <a:srgbClr val="1A1F27"/>
+                </a:solidFill>
+                <a:latin typeface="Consolas"/>
+              </a:rPr>
+              <a:t>[13] Cust : Thank you, that really helps.</a:t>
+            </a:r>
+          </a:p>
+        </p:txBody>
+      </p:sp>
+      <p:sp>
+        <p:nvSpPr>
+          <p:cNvPr id="5" name="Rounded Rectangle 4"/>
+          <p:cNvSpPr/>
+          <p:nvPr/>
+        </p:nvSpPr>
+        <p:spPr>
+          <a:xfrm>
+            <a:off x="6949440" y="1737360"/>
+            <a:ext cx="4617720" cy="4069080"/>
           </a:xfrm>
           <a:prstGeom prst="roundRect">
             <a:avLst/>
@@ -6035,7 +6222,7 @@
                 </a:solidFill>
                 <a:latin typeface="Segoe UI"/>
               </a:rPr>
-              <a:t>FAIRNESS CHECK · language-proficiency score</a:t>
+              <a:t>WHAT RESPONSIBLE AI ADDS</a:t>
             </a:r>
           </a:p>
           <a:p>
@@ -6051,7 +6238,7 @@
                 </a:solidFill>
                 <a:latin typeface="Segoe UI"/>
               </a:rPr>
-              <a:t>Compare average scores by group:</a:t>
+              <a:t>The pipeline scores this call:</a:t>
             </a:r>
           </a:p>
           <a:p>
@@ -6067,7 +6254,7 @@
                 </a:solidFill>
                 <a:latin typeface="Consolas"/>
               </a:rPr>
-              <a:t>native speakers      : 0.86</a:t>
+              <a:t>empathy    = 0.9   ← line 11</a:t>
             </a:r>
           </a:p>
           <a:p>
@@ -6083,7 +6270,7 @@
                 </a:solidFill>
                 <a:latin typeface="Consolas"/>
               </a:rPr>
-              <a:t>non-native speakers  : 0.71</a:t>
+              <a:t>ownership  = yes   ← line 12</a:t>
             </a:r>
           </a:p>
           <a:p>
@@ -6095,11 +6282,11 @@
             <a:r>
               <a:rPr sz="1150" b="0">
                 <a:solidFill>
-                  <a:srgbClr val="A96E12"/>
+                  <a:srgbClr val="0A5B55"/>
                 </a:solidFill>
                 <a:latin typeface="Consolas"/>
               </a:rPr>
-              <a:t>gap                  : 0.15  → review</a:t>
+              <a:t>experience = Good  ← line 13</a:t>
             </a:r>
           </a:p>
           <a:p>
@@ -6127,11 +6314,11 @@
             <a:r>
               <a:rPr sz="1150" b="0">
                 <a:solidFill>
-                  <a:srgbClr val="535C6A"/>
+                  <a:srgbClr val="2E8B5E"/>
                 </a:solidFill>
                 <a:latin typeface="Segoe UI"/>
               </a:rPr>
-              <a:t>A gap isn't proof of bias — but we LOOK,</a:t>
+              <a:t>Transparency — the agent sees the</a:t>
             </a:r>
           </a:p>
           <a:p>
@@ -6147,66 +6334,7 @@
                 </a:solidFill>
                 <a:latin typeface="Segoe UI"/>
               </a:rPr>
-              <a:t>measure, and explain it, not assume.</a:t>
-            </a:r>
-          </a:p>
-        </p:txBody>
-      </p:sp>
-      <p:sp>
-        <p:nvSpPr>
-          <p:cNvPr id="5" name="Rounded Rectangle 4"/>
-          <p:cNvSpPr/>
-          <p:nvPr/>
-        </p:nvSpPr>
-        <p:spPr>
-          <a:xfrm>
-            <a:off x="6355080" y="1828800"/>
-            <a:ext cx="5212080" cy="3657600"/>
-          </a:xfrm>
-          <a:prstGeom prst="roundRect">
-            <a:avLst/>
-          </a:prstGeom>
-          <a:solidFill>
-            <a:srgbClr val="E1F0EE"/>
-          </a:solidFill>
-          <a:ln w="9525">
-            <a:solidFill>
-              <a:srgbClr val="D9DFE5"/>
-            </a:solidFill>
-          </a:ln>
-          <a:effectLst/>
-        </p:spPr>
-        <p:style>
-          <a:lnRef idx="1">
-            <a:schemeClr val="accent1"/>
-          </a:lnRef>
-          <a:fillRef idx="3">
-            <a:schemeClr val="accent1"/>
-          </a:fillRef>
-          <a:effectRef idx="2">
-            <a:schemeClr val="accent1"/>
-          </a:effectRef>
-          <a:fontRef idx="minor">
-            <a:schemeClr val="lt1"/>
-          </a:fontRef>
-        </p:style>
-        <p:txBody>
-          <a:bodyPr rtlCol="0" anchor="ctr" wrap="square" lIns="146304" rIns="128016" tIns="118872" bIns="91440"/>
-          <a:lstStyle/>
-          <a:p>
-            <a:pPr algn="ctr">
-              <a:spcAft>
-                <a:spcPts val="700"/>
-              </a:spcAft>
-            </a:pPr>
-            <a:r>
-              <a:rPr sz="1250" b="1">
-                <a:solidFill>
-                  <a:srgbClr val="0E7C74"/>
-                </a:solidFill>
-                <a:latin typeface="Segoe UI"/>
-              </a:rPr>
-              <a:t>TRANSPARENCY · a score with its evidence</a:t>
+              <a:t>exact lines behind each score.</a:t>
             </a:r>
           </a:p>
           <a:p>
@@ -6218,11 +6346,11 @@
             <a:r>
               <a:rPr sz="1150" b="0">
                 <a:solidFill>
-                  <a:srgbClr val="0A5B55"/>
-                </a:solidFill>
-                <a:latin typeface="Consolas"/>
+                  <a:srgbClr val="2E8B5E"/>
+                </a:solidFill>
+                <a:latin typeface="Segoe UI"/>
               </a:rPr>
-              <a:t>empathy = 0.9</a:t>
+              <a:t>Contestable — if they disagree they</a:t>
             </a:r>
           </a:p>
           <a:p>
@@ -6238,87 +6366,7 @@
                 </a:solidFill>
                 <a:latin typeface="Segoe UI"/>
               </a:rPr>
-              <a:t>because, on call #4471:</a:t>
-            </a:r>
-          </a:p>
-          <a:p>
-            <a:pPr>
-              <a:spcAft>
-                <a:spcPts val="300"/>
-              </a:spcAft>
-            </a:pPr>
-            <a:r>
-              <a:rPr sz="1150" b="0">
-                <a:solidFill>
-                  <a:srgbClr val="0A5B55"/>
-                </a:solidFill>
-                <a:latin typeface="Consolas"/>
-              </a:rPr>
-              <a:t>  “I completely understand,</a:t>
-            </a:r>
-          </a:p>
-          <a:p>
-            <a:pPr>
-              <a:spcAft>
-                <a:spcPts val="300"/>
-              </a:spcAft>
-            </a:pPr>
-            <a:r>
-              <a:rPr sz="1150" b="0">
-                <a:solidFill>
-                  <a:srgbClr val="0A5B55"/>
-                </a:solidFill>
-                <a:latin typeface="Consolas"/>
-              </a:rPr>
-              <a:t>   let me sort this for you.”</a:t>
-            </a:r>
-          </a:p>
-          <a:p>
-            <a:pPr>
-              <a:spcAft>
-                <a:spcPts val="300"/>
-              </a:spcAft>
-            </a:pPr>
-            <a:r>
-              <a:rPr sz="1150" b="0">
-                <a:solidFill>
-                  <a:srgbClr val="535C6A"/>
-                </a:solidFill>
-                <a:latin typeface="Segoe UI"/>
-              </a:rPr>
-              <a:t>  (lines 12–14)</a:t>
-            </a:r>
-          </a:p>
-          <a:p>
-            <a:pPr>
-              <a:spcAft>
-                <a:spcPts val="300"/>
-              </a:spcAft>
-            </a:pPr>
-            <a:r>
-              <a:rPr sz="1150" b="0">
-                <a:solidFill>
-                  <a:srgbClr val="1A1F27"/>
-                </a:solidFill>
-                <a:latin typeface="Segoe UI"/>
-              </a:rPr>
-              <a:t/>
-            </a:r>
-          </a:p>
-          <a:p>
-            <a:pPr>
-              <a:spcAft>
-                <a:spcPts val="300"/>
-              </a:spcAft>
-            </a:pPr>
-            <a:r>
-              <a:rPr sz="1150" b="0">
-                <a:solidFill>
-                  <a:srgbClr val="2E8B5E"/>
-                </a:solidFill>
-                <a:latin typeface="Segoe UI"/>
-              </a:rPr>
-              <a:t>The agent can see WHY — and challenge it.</a:t>
+              <a:t>can challenge it, evidence in view.</a:t>
             </a:r>
           </a:p>
         </p:txBody>
@@ -6331,7 +6379,7 @@
         </p:nvSpPr>
         <p:spPr>
           <a:xfrm>
-            <a:off x="640080" y="5806440"/>
+            <a:off x="640080" y="5943600"/>
             <a:ext cx="10927080" cy="749808"/>
           </a:xfrm>
           <a:prstGeom prst="roundRect">
@@ -6369,13 +6417,13 @@
               </a:spcAft>
             </a:pPr>
             <a:r>
-              <a:rPr sz="1400" b="1">
+              <a:rPr sz="1250" b="1">
                 <a:solidFill>
                   <a:srgbClr val="0A5B55"/>
                 </a:solidFill>
                 <a:latin typeface="Segoe UI"/>
               </a:rPr>
-              <a:t>Responsible AI turns “trust us” into “here is the check, the number, and the evidence.”</a:t>
+              <a:t>No score without evidence — plus a fairness check on top (native vs non-native averages 0.86 vs 0.71 → flagged for review). That is what makes AI that evaluates people defensible.</a:t>
             </a:r>
           </a:p>
         </p:txBody>

</xml_diff>